<commit_message>
Adjust PPTX template and update Changelog
Add ChangeLog entry and replace the standard PPTX template. The PowerPoint template was updated to set the slide title to “Retours terrain” and to align the right borders of the lower blocks; ChangeLog.md was updated to document this adjustment. Files changed: ChangeLog.md, doctemplates/saweeklyreport/weekly_report_standard.pptx.
</commit_message>
<xml_diff>
--- a/doctemplates/saweeklyreport/weekly_report_standard.pptx
+++ b/doctemplates/saweeklyreport/weekly_report_standard.pptx
@@ -2097,7 +2097,7 @@
                 <a:ea typeface="Calibri" pitchFamily="34" charset="-122"/>
                 <a:cs typeface="Calibri" pitchFamily="34" charset="-120"/>
               </a:rPr>
-              <a:t>{{FIELD_RETURNS}}</a:t>
+              <a:t>🚧  Retours terrain</a:t>
             </a:r>
             <a:endParaRPr lang="en-US" sz="1200" dirty="0"/>
           </a:p>
@@ -2136,7 +2136,7 @@
                 <a:ea typeface="Calibri" pitchFamily="34" charset="-122"/>
                 <a:cs typeface="Calibri" pitchFamily="34" charset="-120"/>
               </a:rPr>
-              <a:t/>
+              <a:t>{{FIELD_RETURNS}}</a:t>
             </a:r>
             <a:r>
               <a:rPr lang="en-US" sz="1300" dirty="0">
@@ -2309,7 +2309,7 @@
         <p:spPr>
           <a:xfrm>
             <a:off x="228600" y="3200040"/>
-            <a:ext cx="8686800" cy="640080"/>
+            <a:ext cx="8823960" cy="640080"/>
           </a:xfrm>
           <a:prstGeom prst="rect">
             <a:avLst/>
@@ -2334,7 +2334,7 @@
         <p:spPr>
           <a:xfrm>
             <a:off x="365760" y="3223800"/>
-            <a:ext cx="8412480" cy="280080"/>
+            <a:ext cx="8549640" cy="280080"/>
           </a:xfrm>
           <a:prstGeom prst="rect">
             <a:avLst/>
@@ -2373,7 +2373,7 @@
         <p:spPr>
           <a:xfrm>
             <a:off x="365760" y="3503880"/>
-            <a:ext cx="8412480" cy="280080"/>
+            <a:ext cx="8549640" cy="280080"/>
           </a:xfrm>
           <a:prstGeom prst="rect">
             <a:avLst/>
@@ -2467,7 +2467,7 @@
         <p:spPr>
           <a:xfrm>
             <a:off x="228600" y="3886200"/>
-            <a:ext cx="8686800" cy="640080"/>
+            <a:ext cx="8823960" cy="640080"/>
           </a:xfrm>
           <a:prstGeom prst="rect">
             <a:avLst/>
@@ -2492,7 +2492,7 @@
         <p:spPr>
           <a:xfrm>
             <a:off x="365760" y="3909960"/>
-            <a:ext cx="8412480" cy="280080"/>
+            <a:ext cx="8549640" cy="280080"/>
           </a:xfrm>
           <a:prstGeom prst="rect">
             <a:avLst/>
@@ -2531,7 +2531,7 @@
         <p:spPr>
           <a:xfrm>
             <a:off x="365760" y="4189920"/>
-            <a:ext cx="8412480" cy="280080"/>
+            <a:ext cx="8549640" cy="280080"/>
           </a:xfrm>
           <a:prstGeom prst="rect">
             <a:avLst/>
@@ -2570,7 +2570,7 @@
         <p:spPr>
           <a:xfrm>
             <a:off x="228600" y="4572360"/>
-            <a:ext cx="8686800" cy="548640"/>
+            <a:ext cx="8823960" cy="548640"/>
           </a:xfrm>
           <a:prstGeom prst="rect">
             <a:avLst/>
@@ -2595,7 +2595,7 @@
         <p:spPr>
           <a:xfrm>
             <a:off x="365760" y="4595400"/>
-            <a:ext cx="8412480" cy="274320"/>
+            <a:ext cx="8549640" cy="274320"/>
           </a:xfrm>
           <a:prstGeom prst="rect">
             <a:avLst/>

</xml_diff>

<commit_message>
Update weekly report PowerPoint template
Replace doctemplates/saweeklyreport/weekly_report_standard.pptx with an updated binary PowerPoint template. This commit updates the standard weekly report presentation (binary file change) to reflect template/layout/content revisions.
</commit_message>
<xml_diff>
--- a/doctemplates/saweeklyreport/weekly_report_standard.pptx
+++ b/doctemplates/saweeklyreport/weekly_report_standard.pptx
@@ -108,7 +108,18 @@
   </p:defaultTextStyle>
   <p:extLst>
     <p:ext uri="{EFAFB233-063F-42B5-8137-9DF3F51BA10A}">
-      <p15:sldGuideLst xmlns:p15="http://schemas.microsoft.com/office/powerpoint/2012/main"/>
+      <p15:sldGuideLst xmlns:p15="http://schemas.microsoft.com/office/powerpoint/2012/main">
+        <p15:guide id="1" orient="horz" pos="1620" userDrawn="1">
+          <p15:clr>
+            <a:srgbClr val="A4A3A4"/>
+          </p15:clr>
+        </p15:guide>
+        <p15:guide id="2" pos="2880" userDrawn="1">
+          <p15:clr>
+            <a:srgbClr val="A4A3A4"/>
+          </p15:clr>
+        </p15:guide>
+      </p15:sldGuideLst>
     </p:ext>
   </p:extLst>
 </p:presentation>
@@ -2047,7 +2058,7 @@
         </p:nvSpPr>
         <p:spPr>
           <a:xfrm>
-            <a:off x="3246120" y="685800"/>
+            <a:off x="3177540" y="685800"/>
             <a:ext cx="2788920" cy="2423160"/>
           </a:xfrm>
           <a:prstGeom prst="rect">
@@ -2072,7 +2083,7 @@
         </p:nvSpPr>
         <p:spPr>
           <a:xfrm>
-            <a:off x="3383280" y="822960"/>
+            <a:off x="3314700" y="760680"/>
             <a:ext cx="2514600" cy="548640"/>
           </a:xfrm>
           <a:prstGeom prst="rect">
@@ -2111,8 +2122,8 @@
         </p:nvSpPr>
         <p:spPr>
           <a:xfrm>
-            <a:off x="3383280" y="1463040"/>
-            <a:ext cx="2514600" cy="731520"/>
+            <a:off x="3314700" y="1505400"/>
+            <a:ext cx="2514600" cy="463920"/>
           </a:xfrm>
           <a:prstGeom prst="rect">
             <a:avLst/>
@@ -2124,76 +2135,16 @@
           <a:bodyPr wrap="square" lIns="0" tIns="0" rIns="0" bIns="0" rtlCol="0" anchor="ctr"/>
           <a:lstStyle/>
           <a:p>
-            <a:pPr marL="0" indent="0">
-              <a:buNone/>
-            </a:pPr>
-            <a:r>
-              <a:rPr lang="en-US" sz="1300" dirty="0" err="1">
+            <a:r>
+              <a:rPr lang="en-US" sz="1500" b="1" dirty="0">
                 <a:solidFill>
                   <a:srgbClr val="FFFFFF"/>
                 </a:solidFill>
                 <a:latin typeface="Calibri" pitchFamily="34" charset="0"/>
-                <a:ea typeface="Calibri" pitchFamily="34" charset="-122"/>
                 <a:cs typeface="Calibri" pitchFamily="34" charset="-120"/>
               </a:rPr>
               <a:t>{{FIELD_RETURNS}}</a:t>
             </a:r>
-            <a:r>
-              <a:rPr lang="en-US" sz="1300" dirty="0">
-                <a:solidFill>
-                  <a:srgbClr val="FFFFFF"/>
-                </a:solidFill>
-                <a:latin typeface="Calibri" pitchFamily="34" charset="0"/>
-                <a:ea typeface="Calibri" pitchFamily="34" charset="-122"/>
-                <a:cs typeface="Calibri" pitchFamily="34" charset="-120"/>
-              </a:rPr>
-              <a:t/>
-            </a:r>
-            <a:r>
-              <a:rPr lang="en-US" sz="1300" dirty="0" err="1">
-                <a:solidFill>
-                  <a:srgbClr val="FFFFFF"/>
-                </a:solidFill>
-                <a:latin typeface="Calibri" pitchFamily="34" charset="0"/>
-                <a:ea typeface="Calibri" pitchFamily="34" charset="-122"/>
-                <a:cs typeface="Calibri" pitchFamily="34" charset="-120"/>
-              </a:rPr>
-              <a:t/>
-            </a:r>
-            <a:r>
-              <a:rPr lang="en-US" sz="1300" dirty="0">
-                <a:solidFill>
-                  <a:srgbClr val="FFFFFF"/>
-                </a:solidFill>
-                <a:latin typeface="Calibri" pitchFamily="34" charset="0"/>
-                <a:ea typeface="Calibri" pitchFamily="34" charset="-122"/>
-                <a:cs typeface="Calibri" pitchFamily="34" charset="-120"/>
-              </a:rPr>
-              <a:t/>
-            </a:r>
-            <a:r>
-              <a:rPr lang="en-US" sz="1300" dirty="0" err="1">
-                <a:solidFill>
-                  <a:srgbClr val="FFFFFF"/>
-                </a:solidFill>
-                <a:latin typeface="Calibri" pitchFamily="34" charset="0"/>
-                <a:ea typeface="Calibri" pitchFamily="34" charset="-122"/>
-                <a:cs typeface="Calibri" pitchFamily="34" charset="-120"/>
-              </a:rPr>
-              <a:t/>
-            </a:r>
-            <a:r>
-              <a:rPr lang="en-US" sz="1300" dirty="0">
-                <a:solidFill>
-                  <a:srgbClr val="FFFFFF"/>
-                </a:solidFill>
-                <a:latin typeface="Calibri" pitchFamily="34" charset="0"/>
-                <a:ea typeface="Calibri" pitchFamily="34" charset="-122"/>
-                <a:cs typeface="Calibri" pitchFamily="34" charset="-120"/>
-              </a:rPr>
-              <a:t/>
-            </a:r>
-            <a:endParaRPr lang="en-US" sz="1300" dirty="0"/>
           </a:p>
         </p:txBody>
       </p:sp>
@@ -2205,7 +2156,7 @@
         </p:nvSpPr>
         <p:spPr>
           <a:xfrm>
-            <a:off x="6263640" y="685800"/>
+            <a:off x="6126480" y="685800"/>
             <a:ext cx="2788920" cy="2423160"/>
           </a:xfrm>
           <a:prstGeom prst="rect">
@@ -2230,7 +2181,7 @@
         </p:nvSpPr>
         <p:spPr>
           <a:xfrm>
-            <a:off x="6400800" y="822960"/>
+            <a:off x="6263640" y="822960"/>
             <a:ext cx="2514600" cy="411480"/>
           </a:xfrm>
           <a:prstGeom prst="rect">
@@ -2269,7 +2220,7 @@
         </p:nvSpPr>
         <p:spPr>
           <a:xfrm>
-            <a:off x="6400800" y="1463040"/>
+            <a:off x="6263640" y="1463040"/>
             <a:ext cx="2514600" cy="548640"/>
           </a:xfrm>
           <a:prstGeom prst="rect">
@@ -2309,7 +2260,7 @@
         <p:spPr>
           <a:xfrm>
             <a:off x="228600" y="3200040"/>
-            <a:ext cx="8823960" cy="640080"/>
+            <a:ext cx="8686800" cy="640080"/>
           </a:xfrm>
           <a:prstGeom prst="rect">
             <a:avLst/>
@@ -2346,49 +2297,68 @@
           <a:bodyPr wrap="square" lIns="0" tIns="0" rIns="0" bIns="0" rtlCol="0" anchor="ctr"/>
           <a:lstStyle/>
           <a:p>
+            <a:r>
+              <a:rPr lang="en-US" sz="1300" b="1" dirty="0">
+                <a:solidFill>
+                  <a:srgbClr val="FFFFFF"/>
+                </a:solidFill>
+                <a:latin typeface="Calibri" pitchFamily="34" charset="0"/>
+                <a:ea typeface="Calibri" pitchFamily="34" charset="-122"/>
+                <a:cs typeface="Calibri" pitchFamily="34" charset="-120"/>
+              </a:rPr>
+              <a:t>🔧  SAV &amp; MAINTENANCE — Interventions </a:t>
+            </a:r>
+            <a:r>
+              <a:rPr lang="en-US" sz="1300" b="1" dirty="0" err="1">
+                <a:solidFill>
+                  <a:srgbClr val="FFFFFF"/>
+                </a:solidFill>
+                <a:latin typeface="Calibri" pitchFamily="34" charset="0"/>
+                <a:ea typeface="Calibri" pitchFamily="34" charset="-122"/>
+                <a:cs typeface="Calibri" pitchFamily="34" charset="-120"/>
+              </a:rPr>
+              <a:t>semaine</a:t>
+            </a:r>
+            <a:r>
+              <a:rPr lang="en-US" sz="1300" b="1" dirty="0">
+                <a:solidFill>
+                  <a:srgbClr val="FFFFFF"/>
+                </a:solidFill>
+                <a:latin typeface="Calibri" pitchFamily="34" charset="0"/>
+                <a:ea typeface="Calibri" pitchFamily="34" charset="-122"/>
+                <a:cs typeface="Calibri" pitchFamily="34" charset="-120"/>
+              </a:rPr>
+              <a:t> {{WEEK_LABEL}}</a:t>
+            </a:r>
+            <a:endParaRPr lang="en-US" sz="1300" dirty="0"/>
+          </a:p>
+        </p:txBody>
+      </p:sp>
+      <p:sp>
+        <p:nvSpPr>
+          <p:cNvPr id="16" name="Text 14"/>
+          <p:cNvSpPr/>
+          <p:nvPr/>
+        </p:nvSpPr>
+        <p:spPr>
+          <a:xfrm>
+            <a:off x="365760" y="3503880"/>
+            <a:ext cx="8549640" cy="280080"/>
+          </a:xfrm>
+          <a:prstGeom prst="rect">
+            <a:avLst/>
+          </a:prstGeom>
+          <a:noFill/>
+          <a:ln/>
+        </p:spPr>
+        <p:txBody>
+          <a:bodyPr wrap="square" lIns="0" tIns="0" rIns="0" bIns="0" rtlCol="0" anchor="ctr"/>
+          <a:lstStyle/>
+          <a:p>
             <a:pPr marL="0" indent="0">
               <a:buNone/>
             </a:pPr>
             <a:r>
-              <a:rPr lang="en-US" sz="1300" b="1" dirty="0">
-                <a:solidFill>
-                  <a:srgbClr val="FFFFFF"/>
-                </a:solidFill>
-                <a:latin typeface="Calibri" pitchFamily="34" charset="0"/>
-                <a:ea typeface="Calibri" pitchFamily="34" charset="-122"/>
-                <a:cs typeface="Calibri" pitchFamily="34" charset="-120"/>
-              </a:rPr>
-              <a:t>🔧  SAV &amp; MAINTENANCE — Interventions semaine S23</a:t>
-            </a:r>
-            <a:endParaRPr lang="en-US" sz="1300" dirty="0"/>
-          </a:p>
-        </p:txBody>
-      </p:sp>
-      <p:sp>
-        <p:nvSpPr>
-          <p:cNvPr id="16" name="Text 14"/>
-          <p:cNvSpPr/>
-          <p:nvPr/>
-        </p:nvSpPr>
-        <p:spPr>
-          <a:xfrm>
-            <a:off x="365760" y="3503880"/>
-            <a:ext cx="8549640" cy="280080"/>
-          </a:xfrm>
-          <a:prstGeom prst="rect">
-            <a:avLst/>
-          </a:prstGeom>
-          <a:noFill/>
-          <a:ln/>
-        </p:spPr>
-        <p:txBody>
-          <a:bodyPr wrap="square" lIns="0" tIns="0" rIns="0" bIns="0" rtlCol="0" anchor="ctr"/>
-          <a:lstStyle/>
-          <a:p>
-            <a:pPr marL="0" indent="0">
-              <a:buNone/>
-            </a:pPr>
-            <a:r>
               <a:rPr lang="en-US" sz="1100" dirty="0">
                 <a:solidFill>
                   <a:srgbClr val="E8D5F5"/>
@@ -2399,61 +2369,6 @@
               </a:rPr>
               <a:t>{{SERVICE_SUMMARY}}</a:t>
             </a:r>
-            <a:r>
-              <a:rPr lang="en-US" sz="1100" dirty="0" err="1">
-                <a:solidFill>
-                  <a:srgbClr val="E8D5F5"/>
-                </a:solidFill>
-                <a:latin typeface="Calibri" pitchFamily="34" charset="0"/>
-                <a:ea typeface="Calibri" pitchFamily="34" charset="-122"/>
-                <a:cs typeface="Calibri" pitchFamily="34" charset="-120"/>
-              </a:rPr>
-              <a:t/>
-            </a:r>
-            <a:r>
-              <a:rPr lang="en-US" sz="1100" dirty="0">
-                <a:solidFill>
-                  <a:srgbClr val="E8D5F5"/>
-                </a:solidFill>
-                <a:latin typeface="Calibri" pitchFamily="34" charset="0"/>
-                <a:ea typeface="Calibri" pitchFamily="34" charset="-122"/>
-                <a:cs typeface="Calibri" pitchFamily="34" charset="-120"/>
-              </a:rPr>
-              <a:t/>
-            </a:r>
-            <a:r>
-              <a:rPr lang="en-US" sz="1100" dirty="0" err="1">
-                <a:solidFill>
-                  <a:srgbClr val="E8D5F5"/>
-                </a:solidFill>
-                <a:latin typeface="Calibri" pitchFamily="34" charset="0"/>
-                <a:ea typeface="Calibri" pitchFamily="34" charset="-122"/>
-                <a:cs typeface="Calibri" pitchFamily="34" charset="-120"/>
-              </a:rPr>
-              <a:t/>
-            </a:r>
-            <a:r>
-              <a:rPr lang="en-US" sz="1100">
-                <a:solidFill>
-                  <a:srgbClr val="E8D5F5"/>
-                </a:solidFill>
-                <a:latin typeface="Calibri" pitchFamily="34" charset="0"/>
-                <a:ea typeface="Calibri" pitchFamily="34" charset="-122"/>
-                <a:cs typeface="Calibri" pitchFamily="34" charset="-120"/>
-              </a:rPr>
-              <a:t/>
-            </a:r>
-            <a:r>
-              <a:rPr lang="en-US" sz="1100" dirty="0">
-                <a:solidFill>
-                  <a:srgbClr val="E8D5F5"/>
-                </a:solidFill>
-                <a:latin typeface="Calibri" pitchFamily="34" charset="0"/>
-                <a:ea typeface="Calibri" pitchFamily="34" charset="-122"/>
-                <a:cs typeface="Calibri" pitchFamily="34" charset="-120"/>
-              </a:rPr>
-              <a:t/>
-            </a:r>
             <a:endParaRPr lang="en-US" sz="1100" dirty="0"/>
           </a:p>
         </p:txBody>
@@ -2467,7 +2382,7 @@
         <p:spPr>
           <a:xfrm>
             <a:off x="228600" y="3886200"/>
-            <a:ext cx="8823960" cy="640080"/>
+            <a:ext cx="8686800" cy="640080"/>
           </a:xfrm>
           <a:prstGeom prst="rect">
             <a:avLst/>
@@ -2504,49 +2419,68 @@
           <a:bodyPr wrap="square" lIns="0" tIns="0" rIns="0" bIns="0" rtlCol="0" anchor="ctr"/>
           <a:lstStyle/>
           <a:p>
+            <a:r>
+              <a:rPr lang="en-US" sz="1300" b="1" dirty="0">
+                <a:solidFill>
+                  <a:srgbClr val="FFFFFF"/>
+                </a:solidFill>
+                <a:latin typeface="Calibri" pitchFamily="34" charset="0"/>
+                <a:ea typeface="Calibri" pitchFamily="34" charset="-122"/>
+                <a:cs typeface="Calibri" pitchFamily="34" charset="-120"/>
+              </a:rPr>
+              <a:t>👷  TECHNICIENS MOBILISÉS — </a:t>
+            </a:r>
+            <a:r>
+              <a:rPr lang="en-US" sz="1300" b="1" dirty="0" err="1">
+                <a:solidFill>
+                  <a:srgbClr val="FFFFFF"/>
+                </a:solidFill>
+                <a:latin typeface="Calibri" pitchFamily="34" charset="0"/>
+                <a:ea typeface="Calibri" pitchFamily="34" charset="-122"/>
+                <a:cs typeface="Calibri" pitchFamily="34" charset="-120"/>
+              </a:rPr>
+              <a:t>Semaine</a:t>
+            </a:r>
+            <a:r>
+              <a:rPr lang="en-US" sz="1300" b="1" dirty="0">
+                <a:solidFill>
+                  <a:srgbClr val="FFFFFF"/>
+                </a:solidFill>
+                <a:latin typeface="Calibri" pitchFamily="34" charset="0"/>
+                <a:ea typeface="Calibri" pitchFamily="34" charset="-122"/>
+                <a:cs typeface="Calibri" pitchFamily="34" charset="-120"/>
+              </a:rPr>
+              <a:t> {{WEEK_LABEL}}</a:t>
+            </a:r>
+            <a:endParaRPr lang="en-US" sz="1400" dirty="0"/>
+          </a:p>
+        </p:txBody>
+      </p:sp>
+      <p:sp>
+        <p:nvSpPr>
+          <p:cNvPr id="19" name="Text 17"/>
+          <p:cNvSpPr/>
+          <p:nvPr/>
+        </p:nvSpPr>
+        <p:spPr>
+          <a:xfrm>
+            <a:off x="365760" y="4189920"/>
+            <a:ext cx="8549640" cy="280080"/>
+          </a:xfrm>
+          <a:prstGeom prst="rect">
+            <a:avLst/>
+          </a:prstGeom>
+          <a:noFill/>
+          <a:ln/>
+        </p:spPr>
+        <p:txBody>
+          <a:bodyPr wrap="square" lIns="0" tIns="0" rIns="0" bIns="0" rtlCol="0" anchor="ctr"/>
+          <a:lstStyle/>
+          <a:p>
             <a:pPr marL="0" indent="0">
               <a:buNone/>
             </a:pPr>
             <a:r>
-              <a:rPr lang="en-US" sz="1300" b="1" dirty="0">
-                <a:solidFill>
-                  <a:srgbClr val="FFFFFF"/>
-                </a:solidFill>
-                <a:latin typeface="Calibri" pitchFamily="34" charset="0"/>
-                <a:ea typeface="Calibri" pitchFamily="34" charset="-122"/>
-                <a:cs typeface="Calibri" pitchFamily="34" charset="-120"/>
-              </a:rPr>
-              <a:t>👷  TECHNICIENS MOBILISÉS — Semaine S23</a:t>
-            </a:r>
-            <a:endParaRPr lang="en-US" sz="1300" dirty="0"/>
-          </a:p>
-        </p:txBody>
-      </p:sp>
-      <p:sp>
-        <p:nvSpPr>
-          <p:cNvPr id="19" name="Text 17"/>
-          <p:cNvSpPr/>
-          <p:nvPr/>
-        </p:nvSpPr>
-        <p:spPr>
-          <a:xfrm>
-            <a:off x="365760" y="4189920"/>
-            <a:ext cx="8549640" cy="280080"/>
-          </a:xfrm>
-          <a:prstGeom prst="rect">
-            <a:avLst/>
-          </a:prstGeom>
-          <a:noFill/>
-          <a:ln/>
-        </p:spPr>
-        <p:txBody>
-          <a:bodyPr wrap="square" lIns="0" tIns="0" rIns="0" bIns="0" rtlCol="0" anchor="ctr"/>
-          <a:lstStyle/>
-          <a:p>
-            <a:pPr marL="0" indent="0">
-              <a:buNone/>
-            </a:pPr>
-            <a:r>
               <a:rPr lang="en-US" sz="1100" dirty="0">
                 <a:solidFill>
                   <a:srgbClr val="AACFAA"/>
@@ -2570,7 +2504,7 @@
         <p:spPr>
           <a:xfrm>
             <a:off x="228600" y="4572360"/>
-            <a:ext cx="8823960" cy="548640"/>
+            <a:ext cx="8686800" cy="548640"/>
           </a:xfrm>
           <a:prstGeom prst="rect">
             <a:avLst/>
@@ -2607,43 +2541,107 @@
           <a:bodyPr wrap="square" lIns="0" tIns="0" rIns="0" bIns="0" rtlCol="0" anchor="ctr"/>
           <a:lstStyle/>
           <a:p>
-            <a:pPr marL="0" indent="0">
+            <a:r>
+              <a:rPr lang="fr-FR" sz="1200" b="1" dirty="0">
+                <a:solidFill>
+                  <a:srgbClr val="FFFFFF"/>
+                </a:solidFill>
+                <a:latin typeface="Calibri" pitchFamily="34" charset="0"/>
+                <a:ea typeface="Calibri" pitchFamily="34" charset="-122"/>
+                <a:cs typeface="Calibri" pitchFamily="34" charset="-120"/>
+              </a:rPr>
+              <a:t>🦺 MESSAGE SECURIT</a:t>
+            </a:r>
+            <a:r>
+              <a:rPr lang="en-US" sz="1200" b="1" dirty="0">
+                <a:solidFill>
+                  <a:srgbClr val="FFFFFF"/>
+                </a:solidFill>
+                <a:latin typeface="Calibri" pitchFamily="34" charset="0"/>
+                <a:ea typeface="Calibri" pitchFamily="34" charset="-122"/>
+                <a:cs typeface="Calibri" pitchFamily="34" charset="-120"/>
+              </a:rPr>
+              <a:t>É</a:t>
+            </a:r>
+            <a:endParaRPr lang="en-US" sz="1200" dirty="0"/>
+          </a:p>
+        </p:txBody>
+      </p:sp>
+      <p:sp>
+        <p:nvSpPr>
+          <p:cNvPr id="20" name="Text 17">
+            <a:extLst>
+              <a:ext uri="{FF2B5EF4-FFF2-40B4-BE49-F238E27FC236}">
+                <a16:creationId xmlns:a16="http://schemas.microsoft.com/office/drawing/2014/main" id="{82994D02-F026-7490-C82F-4AED491E070D}"/>
+              </a:ext>
+            </a:extLst>
+          </p:cNvPr>
+          <p:cNvSpPr/>
+          <p:nvPr/>
+        </p:nvSpPr>
+        <p:spPr>
+          <a:xfrm>
+            <a:off x="365760" y="4785596"/>
+            <a:ext cx="8549640" cy="280080"/>
+          </a:xfrm>
+          <a:prstGeom prst="rect">
+            <a:avLst/>
+          </a:prstGeom>
+          <a:noFill/>
+          <a:ln/>
+        </p:spPr>
+        <p:txBody>
+          <a:bodyPr wrap="square" lIns="0" tIns="0" rIns="0" bIns="0" rtlCol="0" anchor="ctr"/>
+          <a:lstStyle/>
+          <a:p>
+            <a:pPr marL="0" marR="0" lvl="0" indent="0" algn="l" defTabSz="914400" rtl="0" eaLnBrk="1" fontAlgn="auto" latinLnBrk="0" hangingPunct="1">
+              <a:lnSpc>
+                <a:spcPct val="100000"/>
+              </a:lnSpc>
+              <a:spcBef>
+                <a:spcPts val="0"/>
+              </a:spcBef>
+              <a:spcAft>
+                <a:spcPts val="0"/>
+              </a:spcAft>
+              <a:buClrTx/>
+              <a:buSzTx/>
+              <a:buFontTx/>
               <a:buNone/>
+              <a:tabLst/>
+              <a:defRPr/>
             </a:pPr>
             <a:r>
-              <a:rPr lang="en-US" sz="1200" b="1" dirty="0">
-                <a:solidFill>
-                  <a:srgbClr val="FFFFFF"/>
-                </a:solidFill>
+              <a:rPr kumimoji="0" lang="en-US" sz="1100" b="0" i="0" u="none" strike="noStrike" kern="1200" cap="none" spc="0" normalizeH="0" baseline="0" noProof="0" dirty="0">
+                <a:ln>
+                  <a:noFill/>
+                </a:ln>
+                <a:solidFill>
+                  <a:srgbClr val="AACFAA"/>
+                </a:solidFill>
+                <a:effectLst/>
+                <a:uLnTx/>
+                <a:uFillTx/>
                 <a:latin typeface="Calibri" pitchFamily="34" charset="0"/>
                 <a:ea typeface="Calibri" pitchFamily="34" charset="-122"/>
                 <a:cs typeface="Calibri" pitchFamily="34" charset="-120"/>
               </a:rPr>
               <a:t>{{SAFETY_MESSAGE}}</a:t>
             </a:r>
-            <a:r>
-              <a:rPr lang="en-US" sz="1200" b="1" dirty="0" err="1">
-                <a:solidFill>
-                  <a:srgbClr val="FFFFFF"/>
-                </a:solidFill>
-                <a:latin typeface="Calibri" pitchFamily="34" charset="0"/>
-                <a:ea typeface="Calibri" pitchFamily="34" charset="-122"/>
-                <a:cs typeface="Calibri" pitchFamily="34" charset="-120"/>
-              </a:rPr>
-              <a:t/>
-            </a:r>
-            <a:r>
-              <a:rPr lang="en-US" sz="1200" b="1" dirty="0">
-                <a:solidFill>
-                  <a:srgbClr val="FFFFFF"/>
-                </a:solidFill>
-                <a:latin typeface="Calibri" pitchFamily="34" charset="0"/>
-                <a:ea typeface="Calibri" pitchFamily="34" charset="-122"/>
-                <a:cs typeface="Calibri" pitchFamily="34" charset="-120"/>
-              </a:rPr>
-              <a:t/>
-            </a:r>
-            <a:endParaRPr lang="en-US" sz="1200" dirty="0"/>
+            <a:endParaRPr kumimoji="0" lang="en-US" sz="1100" b="0" i="0" u="none" strike="noStrike" kern="1200" cap="none" spc="0" normalizeH="0" baseline="0" noProof="0" dirty="0">
+              <a:ln>
+                <a:noFill/>
+              </a:ln>
+              <a:solidFill>
+                <a:prstClr val="black"/>
+              </a:solidFill>
+              <a:effectLst/>
+              <a:uLnTx/>
+              <a:uFillTx/>
+              <a:latin typeface="Calibri" panose="020F0502020204030204"/>
+              <a:ea typeface="+mn-ea"/>
+              <a:cs typeface="+mn-cs"/>
+            </a:endParaRPr>
           </a:p>
         </p:txBody>
       </p:sp>

</xml_diff>